<commit_message>
Corrections du deck FX1_slides
</commit_message>
<xml_diff>
--- a/_slides/remanies/14. FX1_slides.pptx
+++ b/_slides/remanies/14. FX1_slides.pptx
@@ -1184,6 +1184,12 @@
               <a:t>D'autres contrôles, la case à cocher et le curseur, attendront le deck suivant, qui en a besoin.</a:t>
             </a:r>
           </a:p>
+          <a:p>
+            <a:r>
+              <a:rPr lang="fr-BE" dirty="0"/>
+              <a:t>Le code complet, à lancer : demos, classe demo.fx.slides.fx1.LanceurInterrupteur.</a:t>
+            </a:r>
+          </a:p>
         </p:txBody>
       </p:sp>
       <p:sp>
@@ -1528,6 +1534,12 @@
               <a:t> est reçu, même si on ne s'en sert pas ici.</a:t>
             </a:r>
           </a:p>
+          <a:p>
+            <a:r>
+              <a:rPr lang="fr-BE" dirty="0"/>
+              <a:t>Le code complet, à lancer : demos, classe demo.fx.slides.fx1.LanceurInterrupteur.</a:t>
+            </a:r>
+          </a:p>
         </p:txBody>
       </p:sp>
       <p:sp>
@@ -1644,6 +1656,12 @@
               <a:t>C'est aussi une question d'examen classique : activer un bouton et en désactiver un autre, en ajoutant et retirant leurs gestionnaires.</a:t>
             </a:r>
           </a:p>
+          <a:p>
+            <a:r>
+              <a:rPr lang="fr-BE" dirty="0"/>
+              <a:t>Le code complet, à lancer : demos, classe demo.fx.slides.fx1.LanceurInterrupteur.</a:t>
+            </a:r>
+          </a:p>
         </p:txBody>
       </p:sp>
       <p:sp>
@@ -2098,6 +2116,12 @@
               <a:t>.</a:t>
             </a:r>
           </a:p>
+          <a:p>
+            <a:r>
+              <a:rPr lang="fr-BE" dirty="0"/>
+              <a:t>Le code complet, à lancer : demos, classe demo.fx.slides.fx1.LanceurInterrupteur.</a:t>
+            </a:r>
+          </a:p>
         </p:txBody>
       </p:sp>
       <p:sp>
@@ -2720,6 +2744,12 @@
               <a:t> vide dit explicitement que les autres touches ne font rien.</a:t>
             </a:r>
           </a:p>
+          <a:p>
+            <a:r>
+              <a:rPr lang="fr-BE" dirty="0"/>
+              <a:t>Le code complet, à lancer : demos, classe demo.fx.slides.fx1.LanceurClavierEtSouris.</a:t>
+            </a:r>
+          </a:p>
         </p:txBody>
       </p:sp>
       <p:sp>
@@ -2876,6 +2906,12 @@
               <a:t> ne survient qu'à la souris. Quand un énoncé demande d'utiliser le clic de souris comme déclencheur, c'est le second qu'il attend.</a:t>
             </a:r>
           </a:p>
+          <a:p>
+            <a:r>
+              <a:rPr lang="fr-BE" dirty="0"/>
+              <a:t>Le code complet, à lancer : demos, classe demo.fx.slides.fx1.LanceurClavierEtSouris.</a:t>
+            </a:r>
+          </a:p>
         </p:txBody>
       </p:sp>
       <p:sp>
@@ -3642,6 +3678,12 @@
               <a:t> arrête le voyage d'un nœud au suivant ; il n'empêche pas les autres gestionnaires posés sur le même nœud de s'exécuter.</a:t>
             </a:r>
           </a:p>
+          <a:p>
+            <a:r>
+              <a:rPr lang="fr-BE" dirty="0"/>
+              <a:t>Le code complet, à lancer : demos, classe demo.fx.slides.fx1.LanceurClavierEtSouris.</a:t>
+            </a:r>
+          </a:p>
         </p:txBody>
       </p:sp>
       <p:sp>
@@ -4054,6 +4096,12 @@
               <a:t>Vous n'avez rien à écrire dans ces classes. Elles sont fournies.</a:t>
             </a:r>
           </a:p>
+          <a:p>
+            <a:r>
+              <a:rPr lang="fr-BE" dirty="0"/>
+              <a:t>Le code complet, à lancer : demos, classe demo.fx.slides.fx1.LanceurLampe.</a:t>
+            </a:r>
+          </a:p>
         </p:txBody>
       </p:sp>
       <p:sp>
@@ -4348,6 +4396,12 @@
               <a:t> se termine en quelques millisecondes, mais la fenêtre reste ouverte et le programme continue de tourner. Ce qu'il fait pendant ce temps est le sujet de la section suivante.</a:t>
             </a:r>
           </a:p>
+          <a:p>
+            <a:r>
+              <a:rPr lang="fr-BE" dirty="0"/>
+              <a:t>Le code complet, à lancer : demos, classe demo.fx.slides.fx1.LanceurLampe.</a:t>
+            </a:r>
+          </a:p>
         </p:txBody>
       </p:sp>
       <p:sp>
@@ -4429,6 +4483,12 @@
             <a:r>
               <a:rPr lang="fr-BE" dirty="0"/>
               <a:t>Pour afficher plusieurs composants, on les range donc dans un conteneur, qui devient la racine. La slide suivante construit cet empilement en code.</a:t>
+            </a:r>
+          </a:p>
+          <a:p>
+            <a:r>
+              <a:rPr lang="fr-BE" dirty="0"/>
+              <a:t>Le code complet, à lancer : demos, classe demo.fx.slides.fx1.LanceurInterrupteur.</a:t>
             </a:r>
           </a:p>
         </p:txBody>
@@ -7796,6 +7856,7 @@
           </a:p>
           <a:p>
             <a:r>
+              <a:rPr/>
               <a:t>Une fenêtre qui réagit</a:t>
             </a:r>
           </a:p>
@@ -8633,7 +8694,7 @@
                     <a:schemeClr val="accent4"/>
                   </a:solidFill>
                 </a:rPr>
-                <a:t>noeuds</a:t>
+                <a:t>nœuds</a:t>
               </a:r>
               <a:endParaRPr lang="fr-FR" dirty="0">
                 <a:solidFill>
@@ -9143,7 +9204,7 @@
                     <a:schemeClr val="accent4"/>
                   </a:solidFill>
                 </a:rPr>
-                <a:t>Ajout d’un enfant après-coup</a:t>
+                <a:t>Ajout d’un enfant après coup</a:t>
               </a:r>
             </a:p>
           </p:txBody>
@@ -22192,7 +22253,7 @@
                       </a:outerShdw>
                     </a:effectLst>
                   </a:rPr>
-                  <a:t>Evénement</a:t>
+                  <a:t>Événement</a:t>
                 </a:r>
               </a:p>
             </p:txBody>
@@ -24382,7 +24443,7 @@
                       </a:outerShdw>
                     </a:effectLst>
                   </a:rPr>
-                  <a:t>Evénement</a:t>
+                  <a:t>Événement</a:t>
                 </a:r>
               </a:p>
             </p:txBody>
@@ -26688,7 +26749,7 @@
                       </a:outerShdw>
                     </a:effectLst>
                   </a:rPr>
-                  <a:t>Evénement</a:t>
+                  <a:t>Événement</a:t>
                 </a:r>
               </a:p>
             </p:txBody>
@@ -27227,7 +27288,7 @@
                       </a:outerShdw>
                     </a:effectLst>
                   </a:rPr>
-                  <a:t>Evénement</a:t>
+                  <a:t>Événement</a:t>
                 </a:r>
               </a:p>
             </p:txBody>
@@ -27766,7 +27827,7 @@
                       </a:outerShdw>
                     </a:effectLst>
                   </a:rPr>
-                  <a:t>Evénement</a:t>
+                  <a:t>Événement</a:t>
                 </a:r>
               </a:p>
             </p:txBody>
@@ -28404,7 +28465,7 @@
                       </a:outerShdw>
                     </a:effectLst>
                   </a:rPr>
-                  <a:t>Evénement</a:t>
+                  <a:t>Événement</a:t>
                 </a:r>
               </a:p>
             </p:txBody>

</xml_diff>